<commit_message>
Updated PPT for generic FPGA devices
</commit_message>
<xml_diff>
--- a/AXI DMA Driver Test Instructions.pptx
+++ b/AXI DMA Driver Test Instructions.pptx
@@ -11,6 +11,7 @@
     <p:sldId id="259" r:id="rId5"/>
     <p:sldId id="260" r:id="rId6"/>
     <p:sldId id="261" r:id="rId7"/>
+    <p:sldId id="262" r:id="rId8"/>
   </p:sldIdLst>
   <p:sldSz cx="12192000" cy="6858000"/>
   <p:notesSz cx="6858000" cy="9144000"/>
@@ -109,6 +110,11 @@
       </a:defRPr>
     </a:lvl9pPr>
   </p:defaultTextStyle>
+  <p:extLst>
+    <p:ext uri="{EFAFB233-063F-42B5-8137-9DF3F51BA10A}">
+      <p15:sldGuideLst xmlns:p15="http://schemas.microsoft.com/office/powerpoint/2012/main"/>
+    </p:ext>
+  </p:extLst>
 </p:presentation>
 </file>
 
@@ -279,6 +285,13 @@
               <a:schemeClr val="lt1"/>
             </a:fontRef>
           </p:style>
+          <p:txBody>
+            <a:bodyPr/>
+            <a:lstStyle/>
+            <a:p>
+              <a:endParaRPr lang="it-IT"/>
+            </a:p>
+          </p:txBody>
         </p:sp>
         <p:sp>
           <p:nvSpPr>
@@ -342,6 +355,13 @@
               <a:schemeClr val="lt1"/>
             </a:fontRef>
           </p:style>
+          <p:txBody>
+            <a:bodyPr/>
+            <a:lstStyle/>
+            <a:p>
+              <a:endParaRPr lang="it-IT"/>
+            </a:p>
+          </p:txBody>
         </p:sp>
         <p:sp>
           <p:nvSpPr>
@@ -383,6 +403,13 @@
               <a:schemeClr val="lt1"/>
             </a:fontRef>
           </p:style>
+          <p:txBody>
+            <a:bodyPr/>
+            <a:lstStyle/>
+            <a:p>
+              <a:endParaRPr lang="it-IT"/>
+            </a:p>
+          </p:txBody>
         </p:sp>
         <p:sp>
           <p:nvSpPr>
@@ -447,6 +474,13 @@
               <a:schemeClr val="lt1"/>
             </a:fontRef>
           </p:style>
+          <p:txBody>
+            <a:bodyPr/>
+            <a:lstStyle/>
+            <a:p>
+              <a:endParaRPr lang="it-IT"/>
+            </a:p>
+          </p:txBody>
         </p:sp>
         <p:sp>
           <p:nvSpPr>
@@ -512,6 +546,13 @@
               <a:schemeClr val="lt1"/>
             </a:fontRef>
           </p:style>
+          <p:txBody>
+            <a:bodyPr/>
+            <a:lstStyle/>
+            <a:p>
+              <a:endParaRPr lang="it-IT"/>
+            </a:p>
+          </p:txBody>
         </p:sp>
         <p:sp>
           <p:nvSpPr>
@@ -575,6 +616,13 @@
               <a:schemeClr val="lt1"/>
             </a:fontRef>
           </p:style>
+          <p:txBody>
+            <a:bodyPr/>
+            <a:lstStyle/>
+            <a:p>
+              <a:endParaRPr lang="it-IT"/>
+            </a:p>
+          </p:txBody>
         </p:sp>
         <p:sp>
           <p:nvSpPr>
@@ -616,6 +664,13 @@
               <a:schemeClr val="lt1"/>
             </a:fontRef>
           </p:style>
+          <p:txBody>
+            <a:bodyPr/>
+            <a:lstStyle/>
+            <a:p>
+              <a:endParaRPr lang="it-IT"/>
+            </a:p>
+          </p:txBody>
         </p:sp>
         <p:sp>
           <p:nvSpPr>
@@ -657,6 +712,13 @@
               <a:schemeClr val="lt1"/>
             </a:fontRef>
           </p:style>
+          <p:txBody>
+            <a:bodyPr/>
+            <a:lstStyle/>
+            <a:p>
+              <a:endParaRPr lang="it-IT"/>
+            </a:p>
+          </p:txBody>
         </p:sp>
       </p:grpSp>
       <p:sp>
@@ -834,7 +896,7 @@
           <a:p>
             <a:fld id="{CFBE34AB-B73E-4B0C-8699-A3D555403971}" type="datetimeFigureOut">
               <a:rPr lang="it-IT" smtClean="0"/>
-              <a:t>06/10/2025</a:t>
+              <a:t>07/11/2025</a:t>
             </a:fld>
             <a:endParaRPr lang="it-IT"/>
           </a:p>
@@ -1085,7 +1147,7 @@
           <a:p>
             <a:fld id="{CFBE34AB-B73E-4B0C-8699-A3D555403971}" type="datetimeFigureOut">
               <a:rPr lang="it-IT" smtClean="0"/>
-              <a:t>06/10/2025</a:t>
+              <a:t>07/11/2025</a:t>
             </a:fld>
             <a:endParaRPr lang="it-IT"/>
           </a:p>
@@ -1399,7 +1461,7 @@
           <a:p>
             <a:fld id="{CFBE34AB-B73E-4B0C-8699-A3D555403971}" type="datetimeFigureOut">
               <a:rPr lang="it-IT" smtClean="0"/>
-              <a:t>06/10/2025</a:t>
+              <a:t>07/11/2025</a:t>
             </a:fld>
             <a:endParaRPr lang="it-IT"/>
           </a:p>
@@ -1740,7 +1802,7 @@
           <a:p>
             <a:fld id="{CFBE34AB-B73E-4B0C-8699-A3D555403971}" type="datetimeFigureOut">
               <a:rPr lang="it-IT" smtClean="0"/>
-              <a:t>06/10/2025</a:t>
+              <a:t>07/11/2025</a:t>
             </a:fld>
             <a:endParaRPr lang="it-IT"/>
           </a:p>
@@ -2054,7 +2116,7 @@
           <a:p>
             <a:fld id="{CFBE34AB-B73E-4B0C-8699-A3D555403971}" type="datetimeFigureOut">
               <a:rPr lang="it-IT" smtClean="0"/>
-              <a:t>06/10/2025</a:t>
+              <a:t>07/11/2025</a:t>
             </a:fld>
             <a:endParaRPr lang="it-IT"/>
           </a:p>
@@ -2447,7 +2509,7 @@
           <a:p>
             <a:fld id="{CFBE34AB-B73E-4B0C-8699-A3D555403971}" type="datetimeFigureOut">
               <a:rPr lang="it-IT" smtClean="0"/>
-              <a:t>06/10/2025</a:t>
+              <a:t>07/11/2025</a:t>
             </a:fld>
             <a:endParaRPr lang="it-IT"/>
           </a:p>
@@ -2617,7 +2679,7 @@
           <a:p>
             <a:fld id="{CFBE34AB-B73E-4B0C-8699-A3D555403971}" type="datetimeFigureOut">
               <a:rPr lang="it-IT" smtClean="0"/>
-              <a:t>06/10/2025</a:t>
+              <a:t>07/11/2025</a:t>
             </a:fld>
             <a:endParaRPr lang="it-IT"/>
           </a:p>
@@ -2797,7 +2859,7 @@
           <a:p>
             <a:fld id="{CFBE34AB-B73E-4B0C-8699-A3D555403971}" type="datetimeFigureOut">
               <a:rPr lang="it-IT" smtClean="0"/>
-              <a:t>06/10/2025</a:t>
+              <a:t>07/11/2025</a:t>
             </a:fld>
             <a:endParaRPr lang="it-IT"/>
           </a:p>
@@ -2973,7 +3035,7 @@
           <a:p>
             <a:fld id="{CFBE34AB-B73E-4B0C-8699-A3D555403971}" type="datetimeFigureOut">
               <a:rPr lang="it-IT" smtClean="0"/>
-              <a:t>06/10/2025</a:t>
+              <a:t>07/11/2025</a:t>
             </a:fld>
             <a:endParaRPr lang="it-IT"/>
           </a:p>
@@ -3220,7 +3282,7 @@
           <a:p>
             <a:fld id="{CFBE34AB-B73E-4B0C-8699-A3D555403971}" type="datetimeFigureOut">
               <a:rPr lang="it-IT" smtClean="0"/>
-              <a:t>06/10/2025</a:t>
+              <a:t>07/11/2025</a:t>
             </a:fld>
             <a:endParaRPr lang="it-IT"/>
           </a:p>
@@ -3452,7 +3514,7 @@
           <a:p>
             <a:fld id="{CFBE34AB-B73E-4B0C-8699-A3D555403971}" type="datetimeFigureOut">
               <a:rPr lang="it-IT" smtClean="0"/>
-              <a:t>06/10/2025</a:t>
+              <a:t>07/11/2025</a:t>
             </a:fld>
             <a:endParaRPr lang="it-IT"/>
           </a:p>
@@ -3826,7 +3888,7 @@
           <a:p>
             <a:fld id="{CFBE34AB-B73E-4B0C-8699-A3D555403971}" type="datetimeFigureOut">
               <a:rPr lang="it-IT" smtClean="0"/>
-              <a:t>06/10/2025</a:t>
+              <a:t>07/11/2025</a:t>
             </a:fld>
             <a:endParaRPr lang="it-IT"/>
           </a:p>
@@ -3949,7 +4011,7 @@
           <a:p>
             <a:fld id="{CFBE34AB-B73E-4B0C-8699-A3D555403971}" type="datetimeFigureOut">
               <a:rPr lang="it-IT" smtClean="0"/>
-              <a:t>06/10/2025</a:t>
+              <a:t>07/11/2025</a:t>
             </a:fld>
             <a:endParaRPr lang="it-IT"/>
           </a:p>
@@ -4044,7 +4106,7 @@
           <a:p>
             <a:fld id="{CFBE34AB-B73E-4B0C-8699-A3D555403971}" type="datetimeFigureOut">
               <a:rPr lang="it-IT" smtClean="0"/>
-              <a:t>06/10/2025</a:t>
+              <a:t>07/11/2025</a:t>
             </a:fld>
             <a:endParaRPr lang="it-IT"/>
           </a:p>
@@ -4299,7 +4361,7 @@
           <a:p>
             <a:fld id="{CFBE34AB-B73E-4B0C-8699-A3D555403971}" type="datetimeFigureOut">
               <a:rPr lang="it-IT" smtClean="0"/>
-              <a:t>06/10/2025</a:t>
+              <a:t>07/11/2025</a:t>
             </a:fld>
             <a:endParaRPr lang="it-IT"/>
           </a:p>
@@ -4562,7 +4624,7 @@
           <a:p>
             <a:fld id="{CFBE34AB-B73E-4B0C-8699-A3D555403971}" type="datetimeFigureOut">
               <a:rPr lang="it-IT" smtClean="0"/>
-              <a:t>06/10/2025</a:t>
+              <a:t>07/11/2025</a:t>
             </a:fld>
             <a:endParaRPr lang="it-IT"/>
           </a:p>
@@ -4795,6 +4857,13 @@
               <a:schemeClr val="lt1"/>
             </a:fontRef>
           </p:style>
+          <p:txBody>
+            <a:bodyPr/>
+            <a:lstStyle/>
+            <a:p>
+              <a:endParaRPr lang="it-IT"/>
+            </a:p>
+          </p:txBody>
         </p:sp>
         <p:sp>
           <p:nvSpPr>
@@ -4858,6 +4927,13 @@
               <a:schemeClr val="lt1"/>
             </a:fontRef>
           </p:style>
+          <p:txBody>
+            <a:bodyPr/>
+            <a:lstStyle/>
+            <a:p>
+              <a:endParaRPr lang="it-IT"/>
+            </a:p>
+          </p:txBody>
         </p:sp>
         <p:sp>
           <p:nvSpPr>
@@ -4899,6 +4975,13 @@
               <a:schemeClr val="lt1"/>
             </a:fontRef>
           </p:style>
+          <p:txBody>
+            <a:bodyPr/>
+            <a:lstStyle/>
+            <a:p>
+              <a:endParaRPr lang="it-IT"/>
+            </a:p>
+          </p:txBody>
         </p:sp>
         <p:sp>
           <p:nvSpPr>
@@ -4963,6 +5046,13 @@
               <a:schemeClr val="lt1"/>
             </a:fontRef>
           </p:style>
+          <p:txBody>
+            <a:bodyPr/>
+            <a:lstStyle/>
+            <a:p>
+              <a:endParaRPr lang="it-IT"/>
+            </a:p>
+          </p:txBody>
         </p:sp>
         <p:sp>
           <p:nvSpPr>
@@ -5028,6 +5118,13 @@
               <a:schemeClr val="lt1"/>
             </a:fontRef>
           </p:style>
+          <p:txBody>
+            <a:bodyPr/>
+            <a:lstStyle/>
+            <a:p>
+              <a:endParaRPr lang="it-IT"/>
+            </a:p>
+          </p:txBody>
         </p:sp>
         <p:sp>
           <p:nvSpPr>
@@ -5091,6 +5188,13 @@
               <a:schemeClr val="lt1"/>
             </a:fontRef>
           </p:style>
+          <p:txBody>
+            <a:bodyPr/>
+            <a:lstStyle/>
+            <a:p>
+              <a:endParaRPr lang="it-IT"/>
+            </a:p>
+          </p:txBody>
         </p:sp>
         <p:sp>
           <p:nvSpPr>
@@ -5132,6 +5236,13 @@
               <a:schemeClr val="lt1"/>
             </a:fontRef>
           </p:style>
+          <p:txBody>
+            <a:bodyPr/>
+            <a:lstStyle/>
+            <a:p>
+              <a:endParaRPr lang="it-IT"/>
+            </a:p>
+          </p:txBody>
         </p:sp>
         <p:sp>
           <p:nvSpPr>
@@ -5173,6 +5284,13 @@
               <a:schemeClr val="lt1"/>
             </a:fontRef>
           </p:style>
+          <p:txBody>
+            <a:bodyPr/>
+            <a:lstStyle/>
+            <a:p>
+              <a:endParaRPr lang="it-IT"/>
+            </a:p>
+          </p:txBody>
         </p:sp>
       </p:grpSp>
       <p:sp>
@@ -5305,7 +5423,7 @@
           <a:p>
             <a:fld id="{CFBE34AB-B73E-4B0C-8699-A3D555403971}" type="datetimeFigureOut">
               <a:rPr lang="it-IT" smtClean="0"/>
-              <a:t>06/10/2025</a:t>
+              <a:t>07/11/2025</a:t>
             </a:fld>
             <a:endParaRPr lang="it-IT"/>
           </a:p>
@@ -7840,6 +7958,187 @@
 </p:sld>
 </file>
 
+<file path=ppt/slides/slide7.xml><?xml version="1.0" encoding="utf-8"?>
+<p:sld xmlns:a="http://schemas.openxmlformats.org/drawingml/2006/main" xmlns:r="http://schemas.openxmlformats.org/officeDocument/2006/relationships" xmlns:p="http://schemas.openxmlformats.org/presentationml/2006/main">
+  <p:cSld>
+    <p:spTree>
+      <p:nvGrpSpPr>
+        <p:cNvPr id="1" name=""/>
+        <p:cNvGrpSpPr/>
+        <p:nvPr/>
+      </p:nvGrpSpPr>
+      <p:grpSpPr>
+        <a:xfrm>
+          <a:off x="0" y="0"/>
+          <a:ext cx="0" cy="0"/>
+          <a:chOff x="0" y="0"/>
+          <a:chExt cx="0" cy="0"/>
+        </a:xfrm>
+      </p:grpSpPr>
+      <p:sp>
+        <p:nvSpPr>
+          <p:cNvPr id="2" name="Titolo 1">
+            <a:extLst>
+              <a:ext uri="{FF2B5EF4-FFF2-40B4-BE49-F238E27FC236}">
+                <a16:creationId xmlns:a16="http://schemas.microsoft.com/office/drawing/2014/main" id="{8F07F4C8-D44F-886C-CB1A-0B274707B47F}"/>
+              </a:ext>
+            </a:extLst>
+          </p:cNvPr>
+          <p:cNvSpPr>
+            <a:spLocks noGrp="1"/>
+          </p:cNvSpPr>
+          <p:nvPr>
+            <p:ph type="title"/>
+          </p:nvPr>
+        </p:nvSpPr>
+        <p:spPr/>
+        <p:txBody>
+          <a:bodyPr/>
+          <a:lstStyle/>
+          <a:p>
+            <a:r>
+              <a:rPr lang="it-IT" dirty="0"/>
+              <a:t>On </a:t>
+            </a:r>
+            <a:r>
+              <a:rPr lang="it-IT" dirty="0" err="1"/>
+              <a:t>generic</a:t>
+            </a:r>
+            <a:r>
+              <a:rPr lang="it-IT" dirty="0"/>
+              <a:t> FPGA drivers</a:t>
+            </a:r>
+          </a:p>
+        </p:txBody>
+      </p:sp>
+      <p:sp>
+        <p:nvSpPr>
+          <p:cNvPr id="3" name="Segnaposto contenuto 2">
+            <a:extLst>
+              <a:ext uri="{FF2B5EF4-FFF2-40B4-BE49-F238E27FC236}">
+                <a16:creationId xmlns:a16="http://schemas.microsoft.com/office/drawing/2014/main" id="{91339D68-E95E-4FAA-D056-3C135A30DF68}"/>
+              </a:ext>
+            </a:extLst>
+          </p:cNvPr>
+          <p:cNvSpPr>
+            <a:spLocks noGrp="1"/>
+          </p:cNvSpPr>
+          <p:nvPr>
+            <p:ph idx="1"/>
+          </p:nvPr>
+        </p:nvSpPr>
+        <p:spPr/>
+        <p:txBody>
+          <a:bodyPr/>
+          <a:lstStyle/>
+          <a:p>
+            <a:r>
+              <a:rPr lang="it-IT" dirty="0" err="1"/>
+              <a:t>It</a:t>
+            </a:r>
+            <a:r>
+              <a:rPr lang="it-IT" dirty="0"/>
+              <a:t> </a:t>
+            </a:r>
+            <a:r>
+              <a:rPr lang="it-IT" dirty="0" err="1"/>
+              <a:t>is</a:t>
+            </a:r>
+            <a:r>
+              <a:rPr lang="it-IT" dirty="0"/>
+              <a:t> </a:t>
+            </a:r>
+            <a:r>
+              <a:rPr lang="it-IT" dirty="0" err="1"/>
+              <a:t>possible</a:t>
+            </a:r>
+            <a:r>
+              <a:rPr lang="it-IT" dirty="0"/>
+              <a:t> to </a:t>
+            </a:r>
+            <a:r>
+              <a:rPr lang="it-IT" dirty="0" err="1"/>
+              <a:t>adjust</a:t>
+            </a:r>
+            <a:r>
+              <a:rPr lang="it-IT" dirty="0"/>
+              <a:t> the driver to work for a </a:t>
+            </a:r>
+            <a:r>
+              <a:rPr lang="it-IT" dirty="0" err="1"/>
+              <a:t>generic</a:t>
+            </a:r>
+            <a:r>
+              <a:rPr lang="it-IT" dirty="0"/>
+              <a:t> FPGA </a:t>
+            </a:r>
+            <a:r>
+              <a:rPr lang="it-IT" dirty="0" err="1"/>
+              <a:t>interface</a:t>
+            </a:r>
+            <a:r>
+              <a:rPr lang="it-IT" dirty="0"/>
+              <a:t> by </a:t>
+            </a:r>
+            <a:r>
+              <a:rPr lang="it-IT" dirty="0" err="1"/>
+              <a:t>tweaking</a:t>
+            </a:r>
+            <a:r>
+              <a:rPr lang="it-IT" dirty="0"/>
+              <a:t> the </a:t>
+            </a:r>
+            <a:r>
+              <a:rPr lang="it-IT" dirty="0" err="1"/>
+              <a:t>functions</a:t>
+            </a:r>
+            <a:r>
+              <a:rPr lang="it-IT" dirty="0"/>
+              <a:t> and the device-</a:t>
+            </a:r>
+            <a:r>
+              <a:rPr lang="it-IT" dirty="0" err="1"/>
+              <a:t>tree</a:t>
+            </a:r>
+            <a:r>
+              <a:rPr lang="it-IT" dirty="0"/>
+              <a:t>,</a:t>
+            </a:r>
+            <a:r>
+              <a:rPr lang="en-US" dirty="0"/>
+              <a:t> but implementing it would imply more limited kernel side control of the hardware, or direct control of the hardware from </a:t>
+            </a:r>
+            <a:r>
+              <a:rPr lang="en-US" dirty="0" err="1"/>
+              <a:t>userspace</a:t>
+            </a:r>
+            <a:r>
+              <a:rPr lang="en-US" dirty="0"/>
+              <a:t> using pointers to PL addresses, increasing the risk of runtime errors and crashes. </a:t>
+            </a:r>
+          </a:p>
+          <a:p>
+            <a:r>
+              <a:rPr lang="en-US" dirty="0"/>
+              <a:t>In most cases, a driver specialized to the PL interface in use is preferable.</a:t>
+            </a:r>
+            <a:endParaRPr lang="it-IT" dirty="0"/>
+          </a:p>
+        </p:txBody>
+      </p:sp>
+    </p:spTree>
+    <p:extLst>
+      <p:ext uri="{BB962C8B-B14F-4D97-AF65-F5344CB8AC3E}">
+        <p14:creationId xmlns:p14="http://schemas.microsoft.com/office/powerpoint/2010/main" val="2935065846"/>
+      </p:ext>
+    </p:extLst>
+  </p:cSld>
+  <p:clrMapOvr>
+    <a:masterClrMapping/>
+  </p:clrMapOvr>
+</p:sld>
+</file>
+
 <file path=ppt/theme/theme1.xml><?xml version="1.0" encoding="utf-8"?>
 <a:theme xmlns:a="http://schemas.openxmlformats.org/drawingml/2006/main" name="Sfaccettatura">
   <a:themeElements>

</xml_diff>